<commit_message>
docs: update README and pitch deck with accurate tech stack
- Fix PPT slide 5: replace Weather API with spectrum-ts, Claude Sonnet 4.6 and gpt-image-2 (not GPT-4o)
- Fix PPT slide 3: weather bullet reflects AI-estimated context, not live API
- README: add output description, clarify all 3 services must run

Co-Authored-By: Claude Sonnet 4.6 <noreply@anthropic.com>
</commit_message>
<xml_diff>
--- a/JourneyFrame_Pitch.pptx
+++ b/JourneyFrame_Pitch.pptx
@@ -4220,7 +4220,7 @@
                   <a:srgbClr val="FFFFFF"/>
                 </a:solidFill>
               </a:rPr>
-              <a:t>✦  Checks live weather &amp; local vibe</a:t>
+              <a:t>✦  Adapts to weather, time of day &amp; local vibe</a:t>
             </a:r>
           </a:p>
         </p:txBody>
@@ -6337,7 +6337,7 @@
                   <a:srgbClr val="6C63FF"/>
                 </a:solidFill>
               </a:rPr>
-              <a:t>🌦  Weather API</a:t>
+              <a:t>🧠  Claude Sonnet 4.6</a:t>
             </a:r>
           </a:p>
         </p:txBody>
@@ -6371,7 +6371,7 @@
                   <a:srgbClr val="CCCCDD"/>
                 </a:solidFill>
               </a:rPr>
-              <a:t>Real-time conditions for context enrichment</a:t>
+              <a:t>LLM powering all 6 pipeline stages via RocketRide wave agent</a:t>
             </a:r>
           </a:p>
         </p:txBody>
@@ -6450,7 +6450,7 @@
                   <a:srgbClr val="6C63FF"/>
                 </a:solidFill>
               </a:rPr>
-              <a:t>🖼  Image Generation</a:t>
+              <a:t>🖼  gpt-image-2</a:t>
             </a:r>
           </a:p>
         </p:txBody>
@@ -6484,7 +6484,7 @@
                   <a:srgbClr val="CCCCDD"/>
                 </a:solidFill>
               </a:rPr>
-              <a:t>Cinematic scene image prompts per itinerary stop</a:t>
+              <a:t>Cinematic travel poster generation — one image per full itinerary</a:t>
             </a:r>
           </a:p>
         </p:txBody>
@@ -6563,7 +6563,7 @@
                   <a:srgbClr val="6C63FF"/>
                 </a:solidFill>
               </a:rPr>
-              <a:t>🧠  Claude / GPT-4o</a:t>
+              <a:t>📦  spectrum-ts</a:t>
             </a:r>
           </a:p>
         </p:txBody>
@@ -6597,7 +6597,7 @@
                   <a:srgbClr val="CCCCDD"/>
                 </a:solidFill>
               </a:rPr>
-              <a:t>LLM powering intent parsing, narration, and prompt generation</a:t>
+              <a:t>TypeScript SDK for Photon — persistent Socket.IO iMessage connection</a:t>
             </a:r>
           </a:p>
         </p:txBody>

</xml_diff>